<commit_message>
v5 patch — Creencias y Opiniones Políticas re-construidos con dims correctas
- Patch local de build_sistema_creencias_deck.py: STAT_BOX 378×113, DESC_PT 13
- Patch local de build_opiniones_politicas_deck.py: STAT_BOX 378×113, DESC 13pt, HEADLINE 50pt fijo (sin auto-size)
- Ambos .pptx regenerados con v5 dimensions
- aprendizajes-montador-cc.md actualizado con LECCIÓN CRÍTICA: el agente cloud no debe reutilizar scripts previos del repo sin verificar v5

Fix del bug detectado por Jeremy: los re-runs de Creencias y Opiniones Políticas pushearon decks con dims viejas porque el cazador reutilizó scripts existentes.
</commit_message>
<xml_diff>
--- a/Agentes Hallazgos/opiniones-politicas-deck-flat.pptx
+++ b/Agentes Hallazgos/opiniones-politicas-deck-flat.pptx
@@ -3141,7 +3141,7 @@
           <a:p>
             <a:pPr algn="ctr"/>
             <a:r>
-              <a:rPr sz="3150" b="0" i="0" kern="0" spc="0">
+              <a:rPr sz="5000" b="0" i="0" kern="0" spc="0">
                 <a:solidFill>
                   <a:srgbClr val="FFFFFF"/>
                 </a:solidFill>
@@ -3150,7 +3150,7 @@
               <a:t>6 DE CADA 10 DOMINICANOS SE INFORMA DE POLÍTICA POR REDES SOCIALES. LA TV CAE A SEGUNDO LUGAR, </a:t>
             </a:r>
             <a:r>
-              <a:rPr sz="3150" b="0" i="1" kern="0" spc="0">
+              <a:rPr sz="5000" b="0" i="1" kern="0" spc="0">
                 <a:solidFill>
                   <a:srgbClr val="FFFFFF"/>
                 </a:solidFill>
@@ -3170,7 +3170,7 @@
         <p:spPr>
           <a:xfrm>
             <a:off x="9134475" y="4572000"/>
-            <a:ext cx="19050" cy="2647950"/>
+            <a:ext cx="19050" cy="1457325"/>
           </a:xfrm>
           <a:prstGeom prst="rect">
             <a:avLst/>
@@ -3212,8 +3212,8 @@
         </p:nvSpPr>
         <p:spPr>
           <a:xfrm>
-            <a:off x="1905000" y="4762500"/>
-            <a:ext cx="8382000" cy="1905000"/>
+            <a:off x="4295775" y="4762500"/>
+            <a:ext cx="3600450" cy="1905000"/>
           </a:xfrm>
           <a:prstGeom prst="rect">
             <a:avLst/>
@@ -3247,23 +3247,23 @@
         </p:nvSpPr>
         <p:spPr>
           <a:xfrm>
-            <a:off x="1905000" y="6858000"/>
-            <a:ext cx="8382000" cy="1714500"/>
-          </a:xfrm>
-          <a:prstGeom prst="rect">
-            <a:avLst/>
-          </a:prstGeom>
-          <a:noFill/>
-        </p:spPr>
-        <p:txBody>
-          <a:bodyPr wrap="square" lIns="0" rIns="0" tIns="0" bIns="0">
-            <a:spAutoFit/>
-          </a:bodyPr>
-          <a:lstStyle/>
-          <a:p>
-            <a:pPr algn="ctr"/>
-            <a:r>
-              <a:rPr sz="1650" b="0" i="0" kern="0" spc="0">
+            <a:off x="4295775" y="6858000"/>
+            <a:ext cx="3600450" cy="1076325"/>
+          </a:xfrm>
+          <a:prstGeom prst="rect">
+            <a:avLst/>
+          </a:prstGeom>
+          <a:noFill/>
+        </p:spPr>
+        <p:txBody>
+          <a:bodyPr wrap="square" lIns="0" rIns="0" tIns="0" bIns="0">
+            <a:spAutoFit/>
+          </a:bodyPr>
+          <a:lstStyle/>
+          <a:p>
+            <a:pPr algn="ctr"/>
+            <a:r>
+              <a:rPr sz="1300" b="0" i="0" kern="0" spc="0">
                 <a:solidFill>
                   <a:srgbClr val="FFFFFF"/>
                 </a:solidFill>
@@ -3272,7 +3272,7 @@
               <a:t>usa </a:t>
             </a:r>
             <a:r>
-              <a:rPr sz="1650" b="1" i="0" kern="0" spc="0">
+              <a:rPr sz="1300" b="1" i="0" kern="0" spc="0">
                 <a:solidFill>
                   <a:srgbClr val="FFFFFF"/>
                 </a:solidFill>
@@ -3281,7 +3281,7 @@
               <a:t>redes sociales</a:t>
             </a:r>
             <a:r>
-              <a:rPr sz="1650" b="0" i="0" kern="0" spc="0">
+              <a:rPr sz="1300" b="0" i="0" kern="0" spc="0">
                 <a:solidFill>
                   <a:srgbClr val="FFFFFF"/>
                 </a:solidFill>
@@ -3300,8 +3300,8 @@
         </p:nvSpPr>
         <p:spPr>
           <a:xfrm>
-            <a:off x="8001000" y="4762500"/>
-            <a:ext cx="8382000" cy="1905000"/>
+            <a:off x="10391775" y="4762500"/>
+            <a:ext cx="3600450" cy="1905000"/>
           </a:xfrm>
           <a:prstGeom prst="rect">
             <a:avLst/>
@@ -3335,23 +3335,23 @@
         </p:nvSpPr>
         <p:spPr>
           <a:xfrm>
-            <a:off x="8001000" y="6858000"/>
-            <a:ext cx="8382000" cy="1714500"/>
-          </a:xfrm>
-          <a:prstGeom prst="rect">
-            <a:avLst/>
-          </a:prstGeom>
-          <a:noFill/>
-        </p:spPr>
-        <p:txBody>
-          <a:bodyPr wrap="square" lIns="0" rIns="0" tIns="0" bIns="0">
-            <a:spAutoFit/>
-          </a:bodyPr>
-          <a:lstStyle/>
-          <a:p>
-            <a:pPr algn="ctr"/>
-            <a:r>
-              <a:rPr sz="1650" b="0" i="0" kern="0" spc="0">
+            <a:off x="10391775" y="6858000"/>
+            <a:ext cx="3600450" cy="1076325"/>
+          </a:xfrm>
+          <a:prstGeom prst="rect">
+            <a:avLst/>
+          </a:prstGeom>
+          <a:noFill/>
+        </p:spPr>
+        <p:txBody>
+          <a:bodyPr wrap="square" lIns="0" rIns="0" tIns="0" bIns="0">
+            <a:spAutoFit/>
+          </a:bodyPr>
+          <a:lstStyle/>
+          <a:p>
+            <a:pPr algn="ctr"/>
+            <a:r>
+              <a:rPr sz="1300" b="0" i="0" kern="0" spc="0">
                 <a:solidFill>
                   <a:srgbClr val="FFFFFF"/>
                 </a:solidFill>
@@ -3360,7 +3360,7 @@
               <a:t>declara la </a:t>
             </a:r>
             <a:r>
-              <a:rPr sz="1650" b="1" i="0" kern="0" spc="0">
+              <a:rPr sz="1300" b="1" i="0" kern="0" spc="0">
                 <a:solidFill>
                   <a:srgbClr val="FFFFFF"/>
                 </a:solidFill>
@@ -3369,7 +3369,7 @@
               <a:t>TV</a:t>
             </a:r>
             <a:r>
-              <a:rPr sz="1650" b="0" i="0" kern="0" spc="0">
+              <a:rPr sz="1300" b="0" i="0" kern="0" spc="0">
                 <a:solidFill>
                   <a:srgbClr val="FFFFFF"/>
                 </a:solidFill>
@@ -3465,7 +3465,7 @@
           <a:p>
             <a:pPr algn="ctr"/>
             <a:r>
-              <a:rPr sz="3150" b="0" i="0" kern="0" spc="0">
+              <a:rPr sz="5000" b="0" i="0" kern="0" spc="0">
                 <a:solidFill>
                   <a:srgbClr val="FFFFFF"/>
                 </a:solidFill>
@@ -3474,7 +3474,7 @@
               <a:t>4 DE CADA 10 DOMINICANOS CALIFICAN LA GESTIÓN DEL GOBIERNO COMO "MUY MALA". </a:t>
             </a:r>
             <a:r>
-              <a:rPr sz="3150" b="0" i="1" kern="0" spc="0">
+              <a:rPr sz="5000" b="0" i="1" kern="0" spc="0">
                 <a:solidFill>
                   <a:srgbClr val="FFFFFF"/>
                 </a:solidFill>
@@ -3494,7 +3494,7 @@
         <p:spPr>
           <a:xfrm>
             <a:off x="9134475" y="4572000"/>
-            <a:ext cx="19050" cy="2647950"/>
+            <a:ext cx="19050" cy="1457325"/>
           </a:xfrm>
           <a:prstGeom prst="rect">
             <a:avLst/>
@@ -3536,8 +3536,8 @@
         </p:nvSpPr>
         <p:spPr>
           <a:xfrm>
-            <a:off x="1905000" y="4762500"/>
-            <a:ext cx="8382000" cy="1905000"/>
+            <a:off x="4295775" y="4762500"/>
+            <a:ext cx="3600450" cy="1905000"/>
           </a:xfrm>
           <a:prstGeom prst="rect">
             <a:avLst/>
@@ -3571,23 +3571,23 @@
         </p:nvSpPr>
         <p:spPr>
           <a:xfrm>
-            <a:off x="1905000" y="6858000"/>
-            <a:ext cx="8382000" cy="1714500"/>
-          </a:xfrm>
-          <a:prstGeom prst="rect">
-            <a:avLst/>
-          </a:prstGeom>
-          <a:noFill/>
-        </p:spPr>
-        <p:txBody>
-          <a:bodyPr wrap="square" lIns="0" rIns="0" tIns="0" bIns="0">
-            <a:spAutoFit/>
-          </a:bodyPr>
-          <a:lstStyle/>
-          <a:p>
-            <a:pPr algn="ctr"/>
-            <a:r>
-              <a:rPr sz="1650" b="0" i="0" kern="0" spc="0">
+            <a:off x="4295775" y="6858000"/>
+            <a:ext cx="3600450" cy="1076325"/>
+          </a:xfrm>
+          <a:prstGeom prst="rect">
+            <a:avLst/>
+          </a:prstGeom>
+          <a:noFill/>
+        </p:spPr>
+        <p:txBody>
+          <a:bodyPr wrap="square" lIns="0" rIns="0" tIns="0" bIns="0">
+            <a:spAutoFit/>
+          </a:bodyPr>
+          <a:lstStyle/>
+          <a:p>
+            <a:pPr algn="ctr"/>
+            <a:r>
+              <a:rPr sz="1300" b="0" i="0" kern="0" spc="0">
                 <a:solidFill>
                   <a:srgbClr val="FFFFFF"/>
                 </a:solidFill>
@@ -3596,7 +3596,7 @@
               <a:t>califica la gestión del gobierno actual como "</a:t>
             </a:r>
             <a:r>
-              <a:rPr sz="1650" b="1" i="0" kern="0" spc="0">
+              <a:rPr sz="1300" b="1" i="0" kern="0" spc="0">
                 <a:solidFill>
                   <a:srgbClr val="FFFFFF"/>
                 </a:solidFill>
@@ -3605,7 +3605,7 @@
               <a:t>1 = Muy mala</a:t>
             </a:r>
             <a:r>
-              <a:rPr sz="1650" b="0" i="0" kern="0" spc="0">
+              <a:rPr sz="1300" b="0" i="0" kern="0" spc="0">
                 <a:solidFill>
                   <a:srgbClr val="FFFFFF"/>
                 </a:solidFill>
@@ -3624,8 +3624,8 @@
         </p:nvSpPr>
         <p:spPr>
           <a:xfrm>
-            <a:off x="8001000" y="4762500"/>
-            <a:ext cx="8382000" cy="1905000"/>
+            <a:off x="10391775" y="4762500"/>
+            <a:ext cx="3600450" cy="1905000"/>
           </a:xfrm>
           <a:prstGeom prst="rect">
             <a:avLst/>
@@ -3659,23 +3659,23 @@
         </p:nvSpPr>
         <p:spPr>
           <a:xfrm>
-            <a:off x="8001000" y="6858000"/>
-            <a:ext cx="8382000" cy="1714500"/>
-          </a:xfrm>
-          <a:prstGeom prst="rect">
-            <a:avLst/>
-          </a:prstGeom>
-          <a:noFill/>
-        </p:spPr>
-        <p:txBody>
-          <a:bodyPr wrap="square" lIns="0" rIns="0" tIns="0" bIns="0">
-            <a:spAutoFit/>
-          </a:bodyPr>
-          <a:lstStyle/>
-          <a:p>
-            <a:pPr algn="ctr"/>
-            <a:r>
-              <a:rPr sz="1650" b="0" i="0" kern="0" spc="0">
+            <a:off x="10391775" y="6858000"/>
+            <a:ext cx="3600450" cy="1076325"/>
+          </a:xfrm>
+          <a:prstGeom prst="rect">
+            <a:avLst/>
+          </a:prstGeom>
+          <a:noFill/>
+        </p:spPr>
+        <p:txBody>
+          <a:bodyPr wrap="square" lIns="0" rIns="0" tIns="0" bIns="0">
+            <a:spAutoFit/>
+          </a:bodyPr>
+          <a:lstStyle/>
+          <a:p>
+            <a:pPr algn="ctr"/>
+            <a:r>
+              <a:rPr sz="1300" b="0" i="0" kern="0" spc="0">
                 <a:solidFill>
                   <a:srgbClr val="FFFFFF"/>
                 </a:solidFill>
@@ -3684,7 +3684,7 @@
               <a:t>suma la valoración </a:t>
             </a:r>
             <a:r>
-              <a:rPr sz="1650" b="1" i="0" kern="0" spc="0">
+              <a:rPr sz="1300" b="1" i="0" kern="0" spc="0">
                 <a:solidFill>
                   <a:srgbClr val="FFFFFF"/>
                 </a:solidFill>
@@ -3693,7 +3693,7 @@
               <a:t>positiva (4+5)</a:t>
             </a:r>
             <a:r>
-              <a:rPr sz="1650" b="0" i="0" kern="0" spc="0">
+              <a:rPr sz="1300" b="0" i="0" kern="0" spc="0">
                 <a:solidFill>
                   <a:srgbClr val="FFFFFF"/>
                 </a:solidFill>
@@ -3948,7 +3948,7 @@
           <a:p>
             <a:pPr algn="ctr"/>
             <a:r>
-              <a:rPr sz="3150" b="0" i="0" kern="0" spc="0">
+              <a:rPr sz="5000" b="0" i="0" kern="0" spc="0">
                 <a:solidFill>
                   <a:srgbClr val="FFFFFF"/>
                 </a:solidFill>
@@ -3957,7 +3957,7 @@
               <a:t>EL DESCONTENTO CON EL GOBIERNO PEGA MÁS DURO ABAJO: EL ESTRATO D Y EL ESTRATO E LIDERAN EL "MUY MALO", </a:t>
             </a:r>
             <a:r>
-              <a:rPr sz="3150" b="0" i="1" kern="0" spc="0">
+              <a:rPr sz="5000" b="0" i="1" kern="0" spc="0">
                 <a:solidFill>
                   <a:srgbClr val="FFFFFF"/>
                 </a:solidFill>
@@ -3977,7 +3977,7 @@
         <p:spPr>
           <a:xfrm>
             <a:off x="9134475" y="4572000"/>
-            <a:ext cx="19050" cy="2647950"/>
+            <a:ext cx="19050" cy="1457325"/>
           </a:xfrm>
           <a:prstGeom prst="rect">
             <a:avLst/>
@@ -4019,8 +4019,8 @@
         </p:nvSpPr>
         <p:spPr>
           <a:xfrm>
-            <a:off x="1905000" y="4762500"/>
-            <a:ext cx="8382000" cy="1905000"/>
+            <a:off x="4295775" y="4762500"/>
+            <a:ext cx="3600450" cy="1905000"/>
           </a:xfrm>
           <a:prstGeom prst="rect">
             <a:avLst/>
@@ -4054,23 +4054,23 @@
         </p:nvSpPr>
         <p:spPr>
           <a:xfrm>
-            <a:off x="1905000" y="6858000"/>
-            <a:ext cx="8382000" cy="1714500"/>
-          </a:xfrm>
-          <a:prstGeom prst="rect">
-            <a:avLst/>
-          </a:prstGeom>
-          <a:noFill/>
-        </p:spPr>
-        <p:txBody>
-          <a:bodyPr wrap="square" lIns="0" rIns="0" tIns="0" bIns="0">
-            <a:spAutoFit/>
-          </a:bodyPr>
-          <a:lstStyle/>
-          <a:p>
-            <a:pPr algn="ctr"/>
-            <a:r>
-              <a:rPr sz="1650" b="0" i="0" kern="0" spc="0">
+            <a:off x="4295775" y="6858000"/>
+            <a:ext cx="3600450" cy="1076325"/>
+          </a:xfrm>
+          <a:prstGeom prst="rect">
+            <a:avLst/>
+          </a:prstGeom>
+          <a:noFill/>
+        </p:spPr>
+        <p:txBody>
+          <a:bodyPr wrap="square" lIns="0" rIns="0" tIns="0" bIns="0">
+            <a:spAutoFit/>
+          </a:bodyPr>
+          <a:lstStyle/>
+          <a:p>
+            <a:pPr algn="ctr"/>
+            <a:r>
+              <a:rPr sz="1300" b="0" i="0" kern="0" spc="0">
                 <a:solidFill>
                   <a:srgbClr val="FFFFFF"/>
                 </a:solidFill>
@@ -4079,7 +4079,7 @@
               <a:t>del </a:t>
             </a:r>
             <a:r>
-              <a:rPr sz="1650" b="1" i="0" kern="0" spc="0">
+              <a:rPr sz="1300" b="1" i="0" kern="0" spc="0">
                 <a:solidFill>
                   <a:srgbClr val="FFFFFF"/>
                 </a:solidFill>
@@ -4088,7 +4088,7 @@
               <a:t>estrato E</a:t>
             </a:r>
             <a:r>
-              <a:rPr sz="1650" b="0" i="0" kern="0" spc="0">
+              <a:rPr sz="1300" b="0" i="0" kern="0" spc="0">
                 <a:solidFill>
                   <a:srgbClr val="FFFFFF"/>
                 </a:solidFill>
@@ -4107,8 +4107,8 @@
         </p:nvSpPr>
         <p:spPr>
           <a:xfrm>
-            <a:off x="8001000" y="4762500"/>
-            <a:ext cx="8382000" cy="1905000"/>
+            <a:off x="10391775" y="4762500"/>
+            <a:ext cx="3600450" cy="1905000"/>
           </a:xfrm>
           <a:prstGeom prst="rect">
             <a:avLst/>
@@ -4142,23 +4142,23 @@
         </p:nvSpPr>
         <p:spPr>
           <a:xfrm>
-            <a:off x="8001000" y="6858000"/>
-            <a:ext cx="8382000" cy="1714500"/>
-          </a:xfrm>
-          <a:prstGeom prst="rect">
-            <a:avLst/>
-          </a:prstGeom>
-          <a:noFill/>
-        </p:spPr>
-        <p:txBody>
-          <a:bodyPr wrap="square" lIns="0" rIns="0" tIns="0" bIns="0">
-            <a:spAutoFit/>
-          </a:bodyPr>
-          <a:lstStyle/>
-          <a:p>
-            <a:pPr algn="ctr"/>
-            <a:r>
-              <a:rPr sz="1650" b="0" i="0" kern="0" spc="0">
+            <a:off x="10391775" y="6858000"/>
+            <a:ext cx="3600450" cy="1076325"/>
+          </a:xfrm>
+          <a:prstGeom prst="rect">
+            <a:avLst/>
+          </a:prstGeom>
+          <a:noFill/>
+        </p:spPr>
+        <p:txBody>
+          <a:bodyPr wrap="square" lIns="0" rIns="0" tIns="0" bIns="0">
+            <a:spAutoFit/>
+          </a:bodyPr>
+          <a:lstStyle/>
+          <a:p>
+            <a:pPr algn="ctr"/>
+            <a:r>
+              <a:rPr sz="1300" b="0" i="0" kern="0" spc="0">
                 <a:solidFill>
                   <a:srgbClr val="FFFFFF"/>
                 </a:solidFill>
@@ -4167,7 +4167,7 @@
               <a:t>de los jóvenes de </a:t>
             </a:r>
             <a:r>
-              <a:rPr sz="1650" b="1" i="0" kern="0" spc="0">
+              <a:rPr sz="1300" b="1" i="0" kern="0" spc="0">
                 <a:solidFill>
                   <a:srgbClr val="FFFFFF"/>
                 </a:solidFill>
@@ -4176,7 +4176,7 @@
               <a:t>18-24</a:t>
             </a:r>
             <a:r>
-              <a:rPr sz="1650" b="0" i="0" kern="0" spc="0">
+              <a:rPr sz="1300" b="0" i="0" kern="0" spc="0">
                 <a:solidFill>
                   <a:srgbClr val="FFFFFF"/>
                 </a:solidFill>
@@ -4272,7 +4272,7 @@
           <a:p>
             <a:pPr algn="ctr"/>
             <a:r>
-              <a:rPr sz="3150" b="0" i="0" kern="0" spc="0">
+              <a:rPr sz="5000" b="0" i="0" kern="0" spc="0">
                 <a:solidFill>
                   <a:srgbClr val="FFFFFF"/>
                 </a:solidFill>
@@ -4281,7 +4281,7 @@
               <a:t>VOTAR ES LA ÚNICA FORMA VÁLIDA DE CAMBIO PARA 4 DE CADA 10. EL SEGUNDO LUGAR NO ES PROTESTAR NI ORGANIZARSE — </a:t>
             </a:r>
             <a:r>
-              <a:rPr sz="3150" b="0" i="1" kern="0" spc="0">
+              <a:rPr sz="5000" b="0" i="1" kern="0" spc="0">
                 <a:solidFill>
                   <a:srgbClr val="FFFFFF"/>
                 </a:solidFill>
@@ -4301,7 +4301,7 @@
         <p:spPr>
           <a:xfrm>
             <a:off x="9134475" y="4572000"/>
-            <a:ext cx="19050" cy="2647950"/>
+            <a:ext cx="19050" cy="1457325"/>
           </a:xfrm>
           <a:prstGeom prst="rect">
             <a:avLst/>
@@ -4343,8 +4343,8 @@
         </p:nvSpPr>
         <p:spPr>
           <a:xfrm>
-            <a:off x="1905000" y="4762500"/>
-            <a:ext cx="8382000" cy="1905000"/>
+            <a:off x="4295775" y="4762500"/>
+            <a:ext cx="3600450" cy="1905000"/>
           </a:xfrm>
           <a:prstGeom prst="rect">
             <a:avLst/>
@@ -4378,23 +4378,23 @@
         </p:nvSpPr>
         <p:spPr>
           <a:xfrm>
-            <a:off x="1905000" y="6858000"/>
-            <a:ext cx="8382000" cy="1714500"/>
-          </a:xfrm>
-          <a:prstGeom prst="rect">
-            <a:avLst/>
-          </a:prstGeom>
-          <a:noFill/>
-        </p:spPr>
-        <p:txBody>
-          <a:bodyPr wrap="square" lIns="0" rIns="0" tIns="0" bIns="0">
-            <a:spAutoFit/>
-          </a:bodyPr>
-          <a:lstStyle/>
-          <a:p>
-            <a:pPr algn="ctr"/>
-            <a:r>
-              <a:rPr sz="1650" b="0" i="0" kern="0" spc="0">
+            <a:off x="4295775" y="6858000"/>
+            <a:ext cx="3600450" cy="1076325"/>
+          </a:xfrm>
+          <a:prstGeom prst="rect">
+            <a:avLst/>
+          </a:prstGeom>
+          <a:noFill/>
+        </p:spPr>
+        <p:txBody>
+          <a:bodyPr wrap="square" lIns="0" rIns="0" tIns="0" bIns="0">
+            <a:spAutoFit/>
+          </a:bodyPr>
+          <a:lstStyle/>
+          <a:p>
+            <a:pPr algn="ctr"/>
+            <a:r>
+              <a:rPr sz="1300" b="0" i="0" kern="0" spc="0">
                 <a:solidFill>
                   <a:srgbClr val="FFFFFF"/>
                 </a:solidFill>
@@ -4403,7 +4403,7 @@
               <a:t>considera "</a:t>
             </a:r>
             <a:r>
-              <a:rPr sz="1650" b="1" i="0" kern="0" spc="0">
+              <a:rPr sz="1300" b="1" i="0" kern="0" spc="0">
                 <a:solidFill>
                   <a:srgbClr val="FFFFFF"/>
                 </a:solidFill>
@@ -4412,7 +4412,7 @@
               <a:t>votar en elecciones</a:t>
             </a:r>
             <a:r>
-              <a:rPr sz="1650" b="0" i="0" kern="0" spc="0">
+              <a:rPr sz="1300" b="0" i="0" kern="0" spc="0">
                 <a:solidFill>
                   <a:srgbClr val="FFFFFF"/>
                 </a:solidFill>
@@ -4431,8 +4431,8 @@
         </p:nvSpPr>
         <p:spPr>
           <a:xfrm>
-            <a:off x="8001000" y="4762500"/>
-            <a:ext cx="8382000" cy="1905000"/>
+            <a:off x="10391775" y="4762500"/>
+            <a:ext cx="3600450" cy="1905000"/>
           </a:xfrm>
           <a:prstGeom prst="rect">
             <a:avLst/>
@@ -4466,23 +4466,23 @@
         </p:nvSpPr>
         <p:spPr>
           <a:xfrm>
-            <a:off x="8001000" y="6858000"/>
-            <a:ext cx="8382000" cy="1714500"/>
-          </a:xfrm>
-          <a:prstGeom prst="rect">
-            <a:avLst/>
-          </a:prstGeom>
-          <a:noFill/>
-        </p:spPr>
-        <p:txBody>
-          <a:bodyPr wrap="square" lIns="0" rIns="0" tIns="0" bIns="0">
-            <a:spAutoFit/>
-          </a:bodyPr>
-          <a:lstStyle/>
-          <a:p>
-            <a:pPr algn="ctr"/>
-            <a:r>
-              <a:rPr sz="1650" b="0" i="0" kern="0" spc="0">
+            <a:off x="10391775" y="6858000"/>
+            <a:ext cx="3600450" cy="1076325"/>
+          </a:xfrm>
+          <a:prstGeom prst="rect">
+            <a:avLst/>
+          </a:prstGeom>
+          <a:noFill/>
+        </p:spPr>
+        <p:txBody>
+          <a:bodyPr wrap="square" lIns="0" rIns="0" tIns="0" bIns="0">
+            <a:spAutoFit/>
+          </a:bodyPr>
+          <a:lstStyle/>
+          <a:p>
+            <a:pPr algn="ctr"/>
+            <a:r>
+              <a:rPr sz="1300" b="0" i="0" kern="0" spc="0">
                 <a:solidFill>
                   <a:srgbClr val="FFFFFF"/>
                 </a:solidFill>
@@ -4491,7 +4491,7 @@
               <a:t>eligió "</a:t>
             </a:r>
             <a:r>
-              <a:rPr sz="1650" b="1" i="0" kern="0" spc="0">
+              <a:rPr sz="1300" b="1" i="0" kern="0" spc="0">
                 <a:solidFill>
                   <a:srgbClr val="FFFFFF"/>
                 </a:solidFill>
@@ -4500,7 +4500,7 @@
               <a:t>no creo que ninguna de estas cosas cambie realmente algo</a:t>
             </a:r>
             <a:r>
-              <a:rPr sz="1650" b="0" i="0" kern="0" spc="0">
+              <a:rPr sz="1300" b="0" i="0" kern="0" spc="0">
                 <a:solidFill>
                   <a:srgbClr val="FFFFFF"/>
                 </a:solidFill>
@@ -4755,7 +4755,7 @@
           <a:p>
             <a:pPr algn="ctr"/>
             <a:r>
-              <a:rPr sz="3150" b="0" i="0" kern="0" spc="0">
+              <a:rPr sz="5000" b="0" i="0" kern="0" spc="0">
                 <a:solidFill>
                   <a:srgbClr val="FFFFFF"/>
                 </a:solidFill>
@@ -4764,7 +4764,7 @@
               <a:t>LAS PROTESTAS Y LAS PETICIONES DIGITALES NO LLEGAN AL 7% COMO VÍA DE CAMBIO. </a:t>
             </a:r>
             <a:r>
-              <a:rPr sz="3150" b="0" i="1" kern="0" spc="0">
+              <a:rPr sz="5000" b="0" i="1" kern="0" spc="0">
                 <a:solidFill>
                   <a:srgbClr val="FFFFFF"/>
                 </a:solidFill>
@@ -4783,8 +4783,8 @@
         </p:nvSpPr>
         <p:spPr>
           <a:xfrm>
-            <a:off x="5229225" y="4762500"/>
-            <a:ext cx="7829550" cy="1905000"/>
+            <a:off x="7343775" y="4762500"/>
+            <a:ext cx="3600450" cy="1905000"/>
           </a:xfrm>
           <a:prstGeom prst="rect">
             <a:avLst/>
@@ -4818,23 +4818,23 @@
         </p:nvSpPr>
         <p:spPr>
           <a:xfrm>
-            <a:off x="5229225" y="6858000"/>
-            <a:ext cx="7829550" cy="1714500"/>
-          </a:xfrm>
-          <a:prstGeom prst="rect">
-            <a:avLst/>
-          </a:prstGeom>
-          <a:noFill/>
-        </p:spPr>
-        <p:txBody>
-          <a:bodyPr wrap="square" lIns="0" rIns="0" tIns="0" bIns="0">
-            <a:spAutoFit/>
-          </a:bodyPr>
-          <a:lstStyle/>
-          <a:p>
-            <a:pPr algn="ctr"/>
-            <a:r>
-              <a:rPr sz="1650" b="0" i="0" kern="0" spc="0">
+            <a:off x="7343775" y="6858000"/>
+            <a:ext cx="3600450" cy="1076325"/>
+          </a:xfrm>
+          <a:prstGeom prst="rect">
+            <a:avLst/>
+          </a:prstGeom>
+          <a:noFill/>
+        </p:spPr>
+        <p:txBody>
+          <a:bodyPr wrap="square" lIns="0" rIns="0" tIns="0" bIns="0">
+            <a:spAutoFit/>
+          </a:bodyPr>
+          <a:lstStyle/>
+          <a:p>
+            <a:pPr algn="ctr"/>
+            <a:r>
+              <a:rPr sz="1300" b="0" i="0" kern="0" spc="0">
                 <a:solidFill>
                   <a:srgbClr val="FFFFFF"/>
                 </a:solidFill>
@@ -4843,7 +4843,7 @@
               <a:t>suma las formas de </a:t>
             </a:r>
             <a:r>
-              <a:rPr sz="1650" b="1" i="0" kern="0" spc="0">
+              <a:rPr sz="1300" b="1" i="0" kern="0" spc="0">
                 <a:solidFill>
                   <a:srgbClr val="FFFFFF"/>
                 </a:solidFill>
@@ -4852,7 +4852,7 @@
               <a:t>participación activa</a:t>
             </a:r>
             <a:r>
-              <a:rPr sz="1650" b="0" i="0" kern="0" spc="0">
+              <a:rPr sz="1300" b="0" i="0" kern="0" spc="0">
                 <a:solidFill>
                   <a:srgbClr val="FFFFFF"/>
                 </a:solidFill>
@@ -5107,7 +5107,7 @@
           <a:p>
             <a:pPr algn="ctr"/>
             <a:r>
-              <a:rPr sz="3150" b="0" i="0" kern="0" spc="0">
+              <a:rPr sz="5000" b="0" i="0" kern="0" spc="0">
                 <a:solidFill>
                   <a:srgbClr val="FFFFFF"/>
                 </a:solidFill>
@@ -5116,7 +5116,7 @@
               <a:t>CUANDO SE IMAGINA EL CAMBIO, EL DOMINICANO NO NOMBRA IDEOLOGÍA. NOMBRA CORRUPCIÓN, SALUD, EDUCACIÓN Y SEGURIDAD. </a:t>
             </a:r>
             <a:r>
-              <a:rPr sz="3150" b="0" i="1" kern="0" spc="0">
+              <a:rPr sz="5000" b="0" i="1" kern="0" spc="0">
                 <a:solidFill>
                   <a:srgbClr val="FFFFFF"/>
                 </a:solidFill>
@@ -5408,7 +5408,7 @@
           <a:p>
             <a:pPr algn="ctr"/>
             <a:r>
-              <a:rPr sz="3150" b="0" i="0" kern="0" spc="0">
+              <a:rPr sz="5000" b="0" i="0" kern="0" spc="0">
                 <a:solidFill>
                   <a:srgbClr val="FFFFFF"/>
                 </a:solidFill>
@@ -5417,7 +5417,7 @@
               <a:t>73% DEL DOMINICANO DICE QUE EL SISTEMA POLÍTICO ES NADA O POCO JUSTO. </a:t>
             </a:r>
             <a:r>
-              <a:rPr sz="3150" b="0" i="1" kern="0" spc="0">
+              <a:rPr sz="5000" b="0" i="1" kern="0" spc="0">
                 <a:solidFill>
                   <a:srgbClr val="FFFFFF"/>
                 </a:solidFill>
@@ -5437,7 +5437,7 @@
         <p:spPr>
           <a:xfrm>
             <a:off x="6848475" y="4572000"/>
-            <a:ext cx="19050" cy="2647950"/>
+            <a:ext cx="19050" cy="1457325"/>
           </a:xfrm>
           <a:prstGeom prst="rect">
             <a:avLst/>
@@ -5480,7 +5480,7 @@
         <p:spPr>
           <a:xfrm>
             <a:off x="11420475" y="4572000"/>
-            <a:ext cx="19050" cy="2647950"/>
+            <a:ext cx="19050" cy="1457325"/>
           </a:xfrm>
           <a:prstGeom prst="rect">
             <a:avLst/>
@@ -5522,8 +5522,8 @@
         </p:nvSpPr>
         <p:spPr>
           <a:xfrm>
-            <a:off x="1905000" y="4762500"/>
-            <a:ext cx="5334000" cy="1905000"/>
+            <a:off x="2771775" y="4762500"/>
+            <a:ext cx="3600450" cy="1905000"/>
           </a:xfrm>
           <a:prstGeom prst="rect">
             <a:avLst/>
@@ -5557,23 +5557,23 @@
         </p:nvSpPr>
         <p:spPr>
           <a:xfrm>
-            <a:off x="1905000" y="6858000"/>
-            <a:ext cx="5334000" cy="1714500"/>
-          </a:xfrm>
-          <a:prstGeom prst="rect">
-            <a:avLst/>
-          </a:prstGeom>
-          <a:noFill/>
-        </p:spPr>
-        <p:txBody>
-          <a:bodyPr wrap="square" lIns="0" rIns="0" tIns="0" bIns="0">
-            <a:spAutoFit/>
-          </a:bodyPr>
-          <a:lstStyle/>
-          <a:p>
-            <a:pPr algn="ctr"/>
-            <a:r>
-              <a:rPr sz="1650" b="0" i="0" kern="0" spc="0">
+            <a:off x="2771775" y="6858000"/>
+            <a:ext cx="3600450" cy="1076325"/>
+          </a:xfrm>
+          <a:prstGeom prst="rect">
+            <a:avLst/>
+          </a:prstGeom>
+          <a:noFill/>
+        </p:spPr>
+        <p:txBody>
+          <a:bodyPr wrap="square" lIns="0" rIns="0" tIns="0" bIns="0">
+            <a:spAutoFit/>
+          </a:bodyPr>
+          <a:lstStyle/>
+          <a:p>
+            <a:pPr algn="ctr"/>
+            <a:r>
+              <a:rPr sz="1300" b="0" i="0" kern="0" spc="0">
                 <a:solidFill>
                   <a:srgbClr val="FFFFFF"/>
                 </a:solidFill>
@@ -5582,7 +5582,7 @@
               <a:t>percibe el sistema político como </a:t>
             </a:r>
             <a:r>
-              <a:rPr sz="1650" b="1" i="0" kern="0" spc="0">
+              <a:rPr sz="1300" b="1" i="0" kern="0" spc="0">
                 <a:solidFill>
                   <a:srgbClr val="FFFFFF"/>
                 </a:solidFill>
@@ -5591,7 +5591,7 @@
               <a:t>injusto</a:t>
             </a:r>
             <a:r>
-              <a:rPr sz="1650" b="0" i="0" kern="0" spc="0">
+              <a:rPr sz="1300" b="0" i="0" kern="0" spc="0">
                 <a:solidFill>
                   <a:srgbClr val="FFFFFF"/>
                 </a:solidFill>
@@ -5610,8 +5610,8 @@
         </p:nvSpPr>
         <p:spPr>
           <a:xfrm>
-            <a:off x="6477000" y="4762500"/>
-            <a:ext cx="5334000" cy="1905000"/>
+            <a:off x="7343775" y="4762500"/>
+            <a:ext cx="3600450" cy="1905000"/>
           </a:xfrm>
           <a:prstGeom prst="rect">
             <a:avLst/>
@@ -5645,23 +5645,23 @@
         </p:nvSpPr>
         <p:spPr>
           <a:xfrm>
-            <a:off x="6477000" y="6858000"/>
-            <a:ext cx="5334000" cy="1714500"/>
-          </a:xfrm>
-          <a:prstGeom prst="rect">
-            <a:avLst/>
-          </a:prstGeom>
-          <a:noFill/>
-        </p:spPr>
-        <p:txBody>
-          <a:bodyPr wrap="square" lIns="0" rIns="0" tIns="0" bIns="0">
-            <a:spAutoFit/>
-          </a:bodyPr>
-          <a:lstStyle/>
-          <a:p>
-            <a:pPr algn="ctr"/>
-            <a:r>
-              <a:rPr sz="1650" b="0" i="0" kern="0" spc="0">
+            <a:off x="7343775" y="6858000"/>
+            <a:ext cx="3600450" cy="1076325"/>
+          </a:xfrm>
+          <a:prstGeom prst="rect">
+            <a:avLst/>
+          </a:prstGeom>
+          <a:noFill/>
+        </p:spPr>
+        <p:txBody>
+          <a:bodyPr wrap="square" lIns="0" rIns="0" tIns="0" bIns="0">
+            <a:spAutoFit/>
+          </a:bodyPr>
+          <a:lstStyle/>
+          <a:p>
+            <a:pPr algn="ctr"/>
+            <a:r>
+              <a:rPr sz="1300" b="0" i="0" kern="0" spc="0">
                 <a:solidFill>
                   <a:srgbClr val="FFFFFF"/>
                 </a:solidFill>
@@ -5670,7 +5670,7 @@
               <a:t>de los rangos 25-34, 35-44, 45-54 y </a:t>
             </a:r>
             <a:r>
-              <a:rPr sz="1650" b="1" i="0" kern="0" spc="0">
+              <a:rPr sz="1300" b="1" i="0" kern="0" spc="0">
                 <a:solidFill>
                   <a:srgbClr val="FFFFFF"/>
                 </a:solidFill>
@@ -5679,7 +5679,7 @@
               <a:t>55+</a:t>
             </a:r>
             <a:r>
-              <a:rPr sz="1650" b="0" i="0" kern="0" spc="0">
+              <a:rPr sz="1300" b="0" i="0" kern="0" spc="0">
                 <a:solidFill>
                   <a:srgbClr val="FFFFFF"/>
                 </a:solidFill>
@@ -5698,8 +5698,8 @@
         </p:nvSpPr>
         <p:spPr>
           <a:xfrm>
-            <a:off x="11049000" y="4762500"/>
-            <a:ext cx="5334000" cy="1905000"/>
+            <a:off x="11915775" y="4762500"/>
+            <a:ext cx="3600450" cy="1905000"/>
           </a:xfrm>
           <a:prstGeom prst="rect">
             <a:avLst/>
@@ -5733,23 +5733,23 @@
         </p:nvSpPr>
         <p:spPr>
           <a:xfrm>
-            <a:off x="11049000" y="6858000"/>
-            <a:ext cx="5334000" cy="1714500"/>
-          </a:xfrm>
-          <a:prstGeom prst="rect">
-            <a:avLst/>
-          </a:prstGeom>
-          <a:noFill/>
-        </p:spPr>
-        <p:txBody>
-          <a:bodyPr wrap="square" lIns="0" rIns="0" tIns="0" bIns="0">
-            <a:spAutoFit/>
-          </a:bodyPr>
-          <a:lstStyle/>
-          <a:p>
-            <a:pPr algn="ctr"/>
-            <a:r>
-              <a:rPr sz="1650" b="0" i="0" kern="0" spc="0">
+            <a:off x="11915775" y="6858000"/>
+            <a:ext cx="3600450" cy="1076325"/>
+          </a:xfrm>
+          <a:prstGeom prst="rect">
+            <a:avLst/>
+          </a:prstGeom>
+          <a:noFill/>
+        </p:spPr>
+        <p:txBody>
+          <a:bodyPr wrap="square" lIns="0" rIns="0" tIns="0" bIns="0">
+            <a:spAutoFit/>
+          </a:bodyPr>
+          <a:lstStyle/>
+          <a:p>
+            <a:pPr algn="ctr"/>
+            <a:r>
+              <a:rPr sz="1300" b="0" i="0" kern="0" spc="0">
                 <a:solidFill>
                   <a:srgbClr val="FFFFFF"/>
                 </a:solidFill>
@@ -5758,7 +5758,7 @@
               <a:t>suma la valoración </a:t>
             </a:r>
             <a:r>
-              <a:rPr sz="1650" b="1" i="0" kern="0" spc="0">
+              <a:rPr sz="1300" b="1" i="0" kern="0" spc="0">
                 <a:solidFill>
                   <a:srgbClr val="FFFFFF"/>
                 </a:solidFill>
@@ -5767,7 +5767,7 @@
               <a:t>positiva (4+5)</a:t>
             </a:r>
             <a:r>
-              <a:rPr sz="1650" b="0" i="0" kern="0" spc="0">
+              <a:rPr sz="1300" b="0" i="0" kern="0" spc="0">
                 <a:solidFill>
                   <a:srgbClr val="FFFFFF"/>
                 </a:solidFill>
@@ -6181,7 +6181,7 @@
           <a:p>
             <a:pPr algn="ctr"/>
             <a:r>
-              <a:rPr sz="3150" b="0" i="0" kern="0" spc="0">
+              <a:rPr sz="5000" b="0" i="0" kern="0" spc="0">
                 <a:solidFill>
                   <a:srgbClr val="FFFFFF"/>
                 </a:solidFill>
@@ -6190,7 +6190,7 @@
               <a:t>CASI LA MITAD DEL DOMINICANO ESTÁ MUY DISPUESTO A IRSE DEL PAÍS. </a:t>
             </a:r>
             <a:r>
-              <a:rPr sz="3150" b="0" i="1" kern="0" spc="0">
+              <a:rPr sz="5000" b="0" i="1" kern="0" spc="0">
                 <a:solidFill>
                   <a:srgbClr val="FFFFFF"/>
                 </a:solidFill>
@@ -6210,7 +6210,7 @@
         <p:spPr>
           <a:xfrm>
             <a:off x="9134475" y="4572000"/>
-            <a:ext cx="19050" cy="2647950"/>
+            <a:ext cx="19050" cy="1457325"/>
           </a:xfrm>
           <a:prstGeom prst="rect">
             <a:avLst/>
@@ -6252,8 +6252,8 @@
         </p:nvSpPr>
         <p:spPr>
           <a:xfrm>
-            <a:off x="1905000" y="4762500"/>
-            <a:ext cx="8382000" cy="1905000"/>
+            <a:off x="4295775" y="4762500"/>
+            <a:ext cx="3600450" cy="1905000"/>
           </a:xfrm>
           <a:prstGeom prst="rect">
             <a:avLst/>
@@ -6287,23 +6287,23 @@
         </p:nvSpPr>
         <p:spPr>
           <a:xfrm>
-            <a:off x="1905000" y="6858000"/>
-            <a:ext cx="8382000" cy="1714500"/>
-          </a:xfrm>
-          <a:prstGeom prst="rect">
-            <a:avLst/>
-          </a:prstGeom>
-          <a:noFill/>
-        </p:spPr>
-        <p:txBody>
-          <a:bodyPr wrap="square" lIns="0" rIns="0" tIns="0" bIns="0">
-            <a:spAutoFit/>
-          </a:bodyPr>
-          <a:lstStyle/>
-          <a:p>
-            <a:pPr algn="ctr"/>
-            <a:r>
-              <a:rPr sz="1650" b="0" i="0" kern="0" spc="0">
+            <a:off x="4295775" y="6858000"/>
+            <a:ext cx="3600450" cy="1076325"/>
+          </a:xfrm>
+          <a:prstGeom prst="rect">
+            <a:avLst/>
+          </a:prstGeom>
+          <a:noFill/>
+        </p:spPr>
+        <p:txBody>
+          <a:bodyPr wrap="square" lIns="0" rIns="0" tIns="0" bIns="0">
+            <a:spAutoFit/>
+          </a:bodyPr>
+          <a:lstStyle/>
+          <a:p>
+            <a:pPr algn="ctr"/>
+            <a:r>
+              <a:rPr sz="1300" b="0" i="0" kern="0" spc="0">
                 <a:solidFill>
                   <a:srgbClr val="FFFFFF"/>
                 </a:solidFill>
@@ -6312,7 +6312,7 @@
               <a:t>se declara "</a:t>
             </a:r>
             <a:r>
-              <a:rPr sz="1650" b="1" i="0" kern="0" spc="0">
+              <a:rPr sz="1300" b="1" i="0" kern="0" spc="0">
                 <a:solidFill>
                   <a:srgbClr val="FFFFFF"/>
                 </a:solidFill>
@@ -6321,7 +6321,7 @@
               <a:t>muy dispuesto</a:t>
             </a:r>
             <a:r>
-              <a:rPr sz="1650" b="0" i="0" kern="0" spc="0">
+              <a:rPr sz="1300" b="0" i="0" kern="0" spc="0">
                 <a:solidFill>
                   <a:srgbClr val="FFFFFF"/>
                 </a:solidFill>
@@ -6340,8 +6340,8 @@
         </p:nvSpPr>
         <p:spPr>
           <a:xfrm>
-            <a:off x="8001000" y="4762500"/>
-            <a:ext cx="8382000" cy="1905000"/>
+            <a:off x="10391775" y="4762500"/>
+            <a:ext cx="3600450" cy="1905000"/>
           </a:xfrm>
           <a:prstGeom prst="rect">
             <a:avLst/>
@@ -6375,23 +6375,23 @@
         </p:nvSpPr>
         <p:spPr>
           <a:xfrm>
-            <a:off x="8001000" y="6858000"/>
-            <a:ext cx="8382000" cy="1714500"/>
-          </a:xfrm>
-          <a:prstGeom prst="rect">
-            <a:avLst/>
-          </a:prstGeom>
-          <a:noFill/>
-        </p:spPr>
-        <p:txBody>
-          <a:bodyPr wrap="square" lIns="0" rIns="0" tIns="0" bIns="0">
-            <a:spAutoFit/>
-          </a:bodyPr>
-          <a:lstStyle/>
-          <a:p>
-            <a:pPr algn="ctr"/>
-            <a:r>
-              <a:rPr sz="1650" b="0" i="0" kern="0" spc="0">
+            <a:off x="10391775" y="6858000"/>
+            <a:ext cx="3600450" cy="1076325"/>
+          </a:xfrm>
+          <a:prstGeom prst="rect">
+            <a:avLst/>
+          </a:prstGeom>
+          <a:noFill/>
+        </p:spPr>
+        <p:txBody>
+          <a:bodyPr wrap="square" lIns="0" rIns="0" tIns="0" bIns="0">
+            <a:spAutoFit/>
+          </a:bodyPr>
+          <a:lstStyle/>
+          <a:p>
+            <a:pPr algn="ctr"/>
+            <a:r>
+              <a:rPr sz="1300" b="0" i="0" kern="0" spc="0">
                 <a:solidFill>
                   <a:srgbClr val="FFFFFF"/>
                 </a:solidFill>
@@ -6400,7 +6400,7 @@
               <a:t>se declara "</a:t>
             </a:r>
             <a:r>
-              <a:rPr sz="1650" b="1" i="0" kern="0" spc="0">
+              <a:rPr sz="1300" b="1" i="0" kern="0" spc="0">
                 <a:solidFill>
                   <a:srgbClr val="FFFFFF"/>
                 </a:solidFill>
@@ -6409,7 +6409,7 @@
               <a:t>nada dispuesto</a:t>
             </a:r>
             <a:r>
-              <a:rPr sz="1650" b="0" i="0" kern="0" spc="0">
+              <a:rPr sz="1300" b="0" i="0" kern="0" spc="0">
                 <a:solidFill>
                   <a:srgbClr val="FFFFFF"/>
                 </a:solidFill>
@@ -6664,7 +6664,7 @@
           <a:p>
             <a:pPr algn="ctr"/>
             <a:r>
-              <a:rPr sz="3150" b="0" i="0" kern="0" spc="0">
+              <a:rPr sz="5000" b="0" i="0" kern="0" spc="0">
                 <a:solidFill>
                   <a:srgbClr val="FFFFFF"/>
                 </a:solidFill>
@@ -6673,7 +6673,7 @@
               <a:t>LA DISPOSICIÓN A EMIGRAR SUBE HASTA LOS 54 AÑOS Y LUEGO SE INVIERTE. LOS MAYORES DE 55 PREFIEREN QUEDARSE. </a:t>
             </a:r>
             <a:r>
-              <a:rPr sz="3150" b="0" i="1" kern="0" spc="0">
+              <a:rPr sz="5000" b="0" i="1" kern="0" spc="0">
                 <a:solidFill>
                   <a:srgbClr val="FFFFFF"/>
                 </a:solidFill>
@@ -6693,7 +6693,7 @@
         <p:spPr>
           <a:xfrm>
             <a:off x="9134475" y="4572000"/>
-            <a:ext cx="19050" cy="2647950"/>
+            <a:ext cx="19050" cy="1457325"/>
           </a:xfrm>
           <a:prstGeom prst="rect">
             <a:avLst/>
@@ -6735,8 +6735,8 @@
         </p:nvSpPr>
         <p:spPr>
           <a:xfrm>
-            <a:off x="1905000" y="4762500"/>
-            <a:ext cx="8382000" cy="1905000"/>
+            <a:off x="4295775" y="4762500"/>
+            <a:ext cx="3600450" cy="1905000"/>
           </a:xfrm>
           <a:prstGeom prst="rect">
             <a:avLst/>
@@ -6770,23 +6770,23 @@
         </p:nvSpPr>
         <p:spPr>
           <a:xfrm>
-            <a:off x="1905000" y="6858000"/>
-            <a:ext cx="8382000" cy="1714500"/>
-          </a:xfrm>
-          <a:prstGeom prst="rect">
-            <a:avLst/>
-          </a:prstGeom>
-          <a:noFill/>
-        </p:spPr>
-        <p:txBody>
-          <a:bodyPr wrap="square" lIns="0" rIns="0" tIns="0" bIns="0">
-            <a:spAutoFit/>
-          </a:bodyPr>
-          <a:lstStyle/>
-          <a:p>
-            <a:pPr algn="ctr"/>
-            <a:r>
-              <a:rPr sz="1650" b="0" i="0" kern="0" spc="0">
+            <a:off x="4295775" y="6858000"/>
+            <a:ext cx="3600450" cy="1076325"/>
+          </a:xfrm>
+          <a:prstGeom prst="rect">
+            <a:avLst/>
+          </a:prstGeom>
+          <a:noFill/>
+        </p:spPr>
+        <p:txBody>
+          <a:bodyPr wrap="square" lIns="0" rIns="0" tIns="0" bIns="0">
+            <a:spAutoFit/>
+          </a:bodyPr>
+          <a:lstStyle/>
+          <a:p>
+            <a:pPr algn="ctr"/>
+            <a:r>
+              <a:rPr sz="1300" b="0" i="0" kern="0" spc="0">
                 <a:solidFill>
                   <a:srgbClr val="FFFFFF"/>
                 </a:solidFill>
@@ -6795,7 +6795,7 @@
               <a:t>de los </a:t>
             </a:r>
             <a:r>
-              <a:rPr sz="1650" b="1" i="0" kern="0" spc="0">
+              <a:rPr sz="1300" b="1" i="0" kern="0" spc="0">
                 <a:solidFill>
                   <a:srgbClr val="FFFFFF"/>
                 </a:solidFill>
@@ -6804,7 +6804,7 @@
               <a:t>45-54 años</a:t>
             </a:r>
             <a:r>
-              <a:rPr sz="1650" b="0" i="0" kern="0" spc="0">
+              <a:rPr sz="1300" b="0" i="0" kern="0" spc="0">
                 <a:solidFill>
                   <a:srgbClr val="FFFFFF"/>
                 </a:solidFill>
@@ -6823,8 +6823,8 @@
         </p:nvSpPr>
         <p:spPr>
           <a:xfrm>
-            <a:off x="8001000" y="4762500"/>
-            <a:ext cx="8382000" cy="1905000"/>
+            <a:off x="10391775" y="4762500"/>
+            <a:ext cx="3600450" cy="1905000"/>
           </a:xfrm>
           <a:prstGeom prst="rect">
             <a:avLst/>
@@ -6858,23 +6858,23 @@
         </p:nvSpPr>
         <p:spPr>
           <a:xfrm>
-            <a:off x="8001000" y="6858000"/>
-            <a:ext cx="8382000" cy="1714500"/>
-          </a:xfrm>
-          <a:prstGeom prst="rect">
-            <a:avLst/>
-          </a:prstGeom>
-          <a:noFill/>
-        </p:spPr>
-        <p:txBody>
-          <a:bodyPr wrap="square" lIns="0" rIns="0" tIns="0" bIns="0">
-            <a:spAutoFit/>
-          </a:bodyPr>
-          <a:lstStyle/>
-          <a:p>
-            <a:pPr algn="ctr"/>
-            <a:r>
-              <a:rPr sz="1650" b="0" i="0" kern="0" spc="0">
+            <a:off x="10391775" y="6858000"/>
+            <a:ext cx="3600450" cy="1076325"/>
+          </a:xfrm>
+          <a:prstGeom prst="rect">
+            <a:avLst/>
+          </a:prstGeom>
+          <a:noFill/>
+        </p:spPr>
+        <p:txBody>
+          <a:bodyPr wrap="square" lIns="0" rIns="0" tIns="0" bIns="0">
+            <a:spAutoFit/>
+          </a:bodyPr>
+          <a:lstStyle/>
+          <a:p>
+            <a:pPr algn="ctr"/>
+            <a:r>
+              <a:rPr sz="1300" b="0" i="0" kern="0" spc="0">
                 <a:solidFill>
                   <a:srgbClr val="FFFFFF"/>
                 </a:solidFill>
@@ -6883,7 +6883,7 @@
               <a:t>del </a:t>
             </a:r>
             <a:r>
-              <a:rPr sz="1650" b="1" i="0" kern="0" spc="0">
+              <a:rPr sz="1300" b="1" i="0" kern="0" spc="0">
                 <a:solidFill>
                   <a:srgbClr val="FFFFFF"/>
                 </a:solidFill>
@@ -6892,7 +6892,7 @@
               <a:t>estrato E</a:t>
             </a:r>
             <a:r>
-              <a:rPr sz="1650" b="0" i="0" kern="0" spc="0">
+              <a:rPr sz="1300" b="0" i="0" kern="0" spc="0">
                 <a:solidFill>
                   <a:srgbClr val="FFFFFF"/>
                 </a:solidFill>
@@ -6988,7 +6988,7 @@
           <a:p>
             <a:pPr algn="ctr"/>
             <a:r>
-              <a:rPr sz="3150" b="0" i="0" kern="0" spc="0">
+              <a:rPr sz="5000" b="0" i="0" kern="0" spc="0">
                 <a:solidFill>
                   <a:srgbClr val="FFFFFF"/>
                 </a:solidFill>
@@ -6997,7 +6997,7 @@
               <a:t>80% DE LOS JÓVENES 18-24 SE INFORMA POR REDES. EN EL ESTRATO E, LA TV AÚN GANA. </a:t>
             </a:r>
             <a:r>
-              <a:rPr sz="3150" b="0" i="1" kern="0" spc="0">
+              <a:rPr sz="5000" b="0" i="1" kern="0" spc="0">
                 <a:solidFill>
                   <a:srgbClr val="FFFFFF"/>
                 </a:solidFill>
@@ -7017,7 +7017,7 @@
         <p:spPr>
           <a:xfrm>
             <a:off x="9134475" y="4572000"/>
-            <a:ext cx="19050" cy="2647950"/>
+            <a:ext cx="19050" cy="1457325"/>
           </a:xfrm>
           <a:prstGeom prst="rect">
             <a:avLst/>
@@ -7059,8 +7059,8 @@
         </p:nvSpPr>
         <p:spPr>
           <a:xfrm>
-            <a:off x="1905000" y="4762500"/>
-            <a:ext cx="8382000" cy="1905000"/>
+            <a:off x="4295775" y="4762500"/>
+            <a:ext cx="3600450" cy="1905000"/>
           </a:xfrm>
           <a:prstGeom prst="rect">
             <a:avLst/>
@@ -7094,23 +7094,23 @@
         </p:nvSpPr>
         <p:spPr>
           <a:xfrm>
-            <a:off x="1905000" y="6858000"/>
-            <a:ext cx="8382000" cy="1714500"/>
-          </a:xfrm>
-          <a:prstGeom prst="rect">
-            <a:avLst/>
-          </a:prstGeom>
-          <a:noFill/>
-        </p:spPr>
-        <p:txBody>
-          <a:bodyPr wrap="square" lIns="0" rIns="0" tIns="0" bIns="0">
-            <a:spAutoFit/>
-          </a:bodyPr>
-          <a:lstStyle/>
-          <a:p>
-            <a:pPr algn="ctr"/>
-            <a:r>
-              <a:rPr sz="1650" b="0" i="0" kern="0" spc="0">
+            <a:off x="4295775" y="6858000"/>
+            <a:ext cx="3600450" cy="1076325"/>
+          </a:xfrm>
+          <a:prstGeom prst="rect">
+            <a:avLst/>
+          </a:prstGeom>
+          <a:noFill/>
+        </p:spPr>
+        <p:txBody>
+          <a:bodyPr wrap="square" lIns="0" rIns="0" tIns="0" bIns="0">
+            <a:spAutoFit/>
+          </a:bodyPr>
+          <a:lstStyle/>
+          <a:p>
+            <a:pPr algn="ctr"/>
+            <a:r>
+              <a:rPr sz="1300" b="0" i="0" kern="0" spc="0">
                 <a:solidFill>
                   <a:srgbClr val="FFFFFF"/>
                 </a:solidFill>
@@ -7119,7 +7119,7 @@
               <a:t>de los jóvenes de </a:t>
             </a:r>
             <a:r>
-              <a:rPr sz="1650" b="1" i="0" kern="0" spc="0">
+              <a:rPr sz="1300" b="1" i="0" kern="0" spc="0">
                 <a:solidFill>
                   <a:srgbClr val="FFFFFF"/>
                 </a:solidFill>
@@ -7128,7 +7128,7 @@
               <a:t>18-24 años</a:t>
             </a:r>
             <a:r>
-              <a:rPr sz="1650" b="0" i="0" kern="0" spc="0">
+              <a:rPr sz="1300" b="0" i="0" kern="0" spc="0">
                 <a:solidFill>
                   <a:srgbClr val="FFFFFF"/>
                 </a:solidFill>
@@ -7147,8 +7147,8 @@
         </p:nvSpPr>
         <p:spPr>
           <a:xfrm>
-            <a:off x="8001000" y="4762500"/>
-            <a:ext cx="8382000" cy="1905000"/>
+            <a:off x="10391775" y="4762500"/>
+            <a:ext cx="3600450" cy="1905000"/>
           </a:xfrm>
           <a:prstGeom prst="rect">
             <a:avLst/>
@@ -7182,23 +7182,23 @@
         </p:nvSpPr>
         <p:spPr>
           <a:xfrm>
-            <a:off x="8001000" y="6858000"/>
-            <a:ext cx="8382000" cy="1714500"/>
-          </a:xfrm>
-          <a:prstGeom prst="rect">
-            <a:avLst/>
-          </a:prstGeom>
-          <a:noFill/>
-        </p:spPr>
-        <p:txBody>
-          <a:bodyPr wrap="square" lIns="0" rIns="0" tIns="0" bIns="0">
-            <a:spAutoFit/>
-          </a:bodyPr>
-          <a:lstStyle/>
-          <a:p>
-            <a:pPr algn="ctr"/>
-            <a:r>
-              <a:rPr sz="1650" b="0" i="0" kern="0" spc="0">
+            <a:off x="10391775" y="6858000"/>
+            <a:ext cx="3600450" cy="1076325"/>
+          </a:xfrm>
+          <a:prstGeom prst="rect">
+            <a:avLst/>
+          </a:prstGeom>
+          <a:noFill/>
+        </p:spPr>
+        <p:txBody>
+          <a:bodyPr wrap="square" lIns="0" rIns="0" tIns="0" bIns="0">
+            <a:spAutoFit/>
+          </a:bodyPr>
+          <a:lstStyle/>
+          <a:p>
+            <a:pPr algn="ctr"/>
+            <a:r>
+              <a:rPr sz="1300" b="0" i="0" kern="0" spc="0">
                 <a:solidFill>
                   <a:srgbClr val="FFFFFF"/>
                 </a:solidFill>
@@ -7207,7 +7207,7 @@
               <a:t>del </a:t>
             </a:r>
             <a:r>
-              <a:rPr sz="1650" b="1" i="0" kern="0" spc="0">
+              <a:rPr sz="1300" b="1" i="0" kern="0" spc="0">
                 <a:solidFill>
                   <a:srgbClr val="FFFFFF"/>
                 </a:solidFill>
@@ -7216,7 +7216,7 @@
               <a:t>estrato E</a:t>
             </a:r>
             <a:r>
-              <a:rPr sz="1650" b="0" i="0" kern="0" spc="0">
+              <a:rPr sz="1300" b="0" i="0" kern="0" spc="0">
                 <a:solidFill>
                   <a:srgbClr val="FFFFFF"/>
                 </a:solidFill>
@@ -7312,7 +7312,7 @@
           <a:p>
             <a:pPr algn="ctr"/>
             <a:r>
-              <a:rPr sz="3150" b="0" i="0" kern="0" spc="0">
+              <a:rPr sz="5000" b="0" i="0" kern="0" spc="0">
                 <a:solidFill>
                   <a:srgbClr val="FFFFFF"/>
                 </a:solidFill>
@@ -7321,7 +7321,7 @@
               <a:t>58% DEL DOMINICANO SE DECLARA NADA INTERESADO EN POLÍTICA. EL DESINTERÉS NO ES UNA POSTURA DE MINORÍA — </a:t>
             </a:r>
             <a:r>
-              <a:rPr sz="3150" b="0" i="1" kern="0" spc="0">
+              <a:rPr sz="5000" b="0" i="1" kern="0" spc="0">
                 <a:solidFill>
                   <a:srgbClr val="FFFFFF"/>
                 </a:solidFill>
@@ -7341,7 +7341,7 @@
         <p:spPr>
           <a:xfrm>
             <a:off x="9134475" y="4572000"/>
-            <a:ext cx="19050" cy="2647950"/>
+            <a:ext cx="19050" cy="1457325"/>
           </a:xfrm>
           <a:prstGeom prst="rect">
             <a:avLst/>
@@ -7383,8 +7383,8 @@
         </p:nvSpPr>
         <p:spPr>
           <a:xfrm>
-            <a:off x="1905000" y="4762500"/>
-            <a:ext cx="8382000" cy="1905000"/>
+            <a:off x="4295775" y="4762500"/>
+            <a:ext cx="3600450" cy="1905000"/>
           </a:xfrm>
           <a:prstGeom prst="rect">
             <a:avLst/>
@@ -7418,23 +7418,23 @@
         </p:nvSpPr>
         <p:spPr>
           <a:xfrm>
-            <a:off x="1905000" y="6858000"/>
-            <a:ext cx="8382000" cy="1714500"/>
-          </a:xfrm>
-          <a:prstGeom prst="rect">
-            <a:avLst/>
-          </a:prstGeom>
-          <a:noFill/>
-        </p:spPr>
-        <p:txBody>
-          <a:bodyPr wrap="square" lIns="0" rIns="0" tIns="0" bIns="0">
-            <a:spAutoFit/>
-          </a:bodyPr>
-          <a:lstStyle/>
-          <a:p>
-            <a:pPr algn="ctr"/>
-            <a:r>
-              <a:rPr sz="1650" b="0" i="0" kern="0" spc="0">
+            <a:off x="4295775" y="6858000"/>
+            <a:ext cx="3600450" cy="1076325"/>
+          </a:xfrm>
+          <a:prstGeom prst="rect">
+            <a:avLst/>
+          </a:prstGeom>
+          <a:noFill/>
+        </p:spPr>
+        <p:txBody>
+          <a:bodyPr wrap="square" lIns="0" rIns="0" tIns="0" bIns="0">
+            <a:spAutoFit/>
+          </a:bodyPr>
+          <a:lstStyle/>
+          <a:p>
+            <a:pPr algn="ctr"/>
+            <a:r>
+              <a:rPr sz="1300" b="0" i="0" kern="0" spc="0">
                 <a:solidFill>
                   <a:srgbClr val="FFFFFF"/>
                 </a:solidFill>
@@ -7443,7 +7443,7 @@
               <a:t>se ubica en el punto más bajo de la escala — "</a:t>
             </a:r>
             <a:r>
-              <a:rPr sz="1650" b="1" i="0" kern="0" spc="0">
+              <a:rPr sz="1300" b="1" i="0" kern="0" spc="0">
                 <a:solidFill>
                   <a:srgbClr val="FFFFFF"/>
                 </a:solidFill>
@@ -7452,7 +7452,7 @@
               <a:t>1 = Nada interesado</a:t>
             </a:r>
             <a:r>
-              <a:rPr sz="1650" b="0" i="0" kern="0" spc="0">
+              <a:rPr sz="1300" b="0" i="0" kern="0" spc="0">
                 <a:solidFill>
                   <a:srgbClr val="FFFFFF"/>
                 </a:solidFill>
@@ -7471,8 +7471,8 @@
         </p:nvSpPr>
         <p:spPr>
           <a:xfrm>
-            <a:off x="8001000" y="4762500"/>
-            <a:ext cx="8382000" cy="1905000"/>
+            <a:off x="10391775" y="4762500"/>
+            <a:ext cx="3600450" cy="1905000"/>
           </a:xfrm>
           <a:prstGeom prst="rect">
             <a:avLst/>
@@ -7506,23 +7506,23 @@
         </p:nvSpPr>
         <p:spPr>
           <a:xfrm>
-            <a:off x="8001000" y="6858000"/>
-            <a:ext cx="8382000" cy="1714500"/>
-          </a:xfrm>
-          <a:prstGeom prst="rect">
-            <a:avLst/>
-          </a:prstGeom>
-          <a:noFill/>
-        </p:spPr>
-        <p:txBody>
-          <a:bodyPr wrap="square" lIns="0" rIns="0" tIns="0" bIns="0">
-            <a:spAutoFit/>
-          </a:bodyPr>
-          <a:lstStyle/>
-          <a:p>
-            <a:pPr algn="ctr"/>
-            <a:r>
-              <a:rPr sz="1650" b="0" i="0" kern="0" spc="0">
+            <a:off x="10391775" y="6858000"/>
+            <a:ext cx="3600450" cy="1076325"/>
+          </a:xfrm>
+          <a:prstGeom prst="rect">
+            <a:avLst/>
+          </a:prstGeom>
+          <a:noFill/>
+        </p:spPr>
+        <p:txBody>
+          <a:bodyPr wrap="square" lIns="0" rIns="0" tIns="0" bIns="0">
+            <a:spAutoFit/>
+          </a:bodyPr>
+          <a:lstStyle/>
+          <a:p>
+            <a:pPr algn="ctr"/>
+            <a:r>
+              <a:rPr sz="1300" b="0" i="0" kern="0" spc="0">
                 <a:solidFill>
                   <a:srgbClr val="FFFFFF"/>
                 </a:solidFill>
@@ -7531,7 +7531,7 @@
               <a:t>suma el </a:t>
             </a:r>
             <a:r>
-              <a:rPr sz="1650" b="1" i="0" kern="0" spc="0">
+              <a:rPr sz="1300" b="1" i="0" kern="0" spc="0">
                 <a:solidFill>
                   <a:srgbClr val="FFFFFF"/>
                 </a:solidFill>
@@ -7540,7 +7540,7 @@
               <a:t>interés alto (4+5)</a:t>
             </a:r>
             <a:r>
-              <a:rPr sz="1650" b="0" i="0" kern="0" spc="0">
+              <a:rPr sz="1300" b="0" i="0" kern="0" spc="0">
                 <a:solidFill>
                   <a:srgbClr val="FFFFFF"/>
                 </a:solidFill>
@@ -7795,7 +7795,7 @@
           <a:p>
             <a:pPr algn="ctr"/>
             <a:r>
-              <a:rPr sz="3150" b="0" i="0" kern="0" spc="0">
+              <a:rPr sz="5000" b="0" i="0" kern="0" spc="0">
                 <a:solidFill>
                   <a:srgbClr val="FFFFFF"/>
                 </a:solidFill>
@@ -7804,7 +7804,7 @@
               <a:t>EL DESINTERÉS POLÍTICO TIENE ROSTRO DE MUJER JOVEN. 69% DE LAS 18-24 SE DECLARA NADA INTERESADA — </a:t>
             </a:r>
             <a:r>
-              <a:rPr sz="3150" b="0" i="1" kern="0" spc="0">
+              <a:rPr sz="5000" b="0" i="1" kern="0" spc="0">
                 <a:solidFill>
                   <a:srgbClr val="FFFFFF"/>
                 </a:solidFill>
@@ -7824,7 +7824,7 @@
         <p:spPr>
           <a:xfrm>
             <a:off x="9134475" y="4572000"/>
-            <a:ext cx="19050" cy="2647950"/>
+            <a:ext cx="19050" cy="1457325"/>
           </a:xfrm>
           <a:prstGeom prst="rect">
             <a:avLst/>
@@ -7866,8 +7866,8 @@
         </p:nvSpPr>
         <p:spPr>
           <a:xfrm>
-            <a:off x="1905000" y="4762500"/>
-            <a:ext cx="8382000" cy="1905000"/>
+            <a:off x="4295775" y="4762500"/>
+            <a:ext cx="3600450" cy="1905000"/>
           </a:xfrm>
           <a:prstGeom prst="rect">
             <a:avLst/>
@@ -7901,23 +7901,23 @@
         </p:nvSpPr>
         <p:spPr>
           <a:xfrm>
-            <a:off x="1905000" y="6858000"/>
-            <a:ext cx="8382000" cy="1714500"/>
-          </a:xfrm>
-          <a:prstGeom prst="rect">
-            <a:avLst/>
-          </a:prstGeom>
-          <a:noFill/>
-        </p:spPr>
-        <p:txBody>
-          <a:bodyPr wrap="square" lIns="0" rIns="0" tIns="0" bIns="0">
-            <a:spAutoFit/>
-          </a:bodyPr>
-          <a:lstStyle/>
-          <a:p>
-            <a:pPr algn="ctr"/>
-            <a:r>
-              <a:rPr sz="1650" b="0" i="0" kern="0" spc="0">
+            <a:off x="4295775" y="6858000"/>
+            <a:ext cx="3600450" cy="1076325"/>
+          </a:xfrm>
+          <a:prstGeom prst="rect">
+            <a:avLst/>
+          </a:prstGeom>
+          <a:noFill/>
+        </p:spPr>
+        <p:txBody>
+          <a:bodyPr wrap="square" lIns="0" rIns="0" tIns="0" bIns="0">
+            <a:spAutoFit/>
+          </a:bodyPr>
+          <a:lstStyle/>
+          <a:p>
+            <a:pPr algn="ctr"/>
+            <a:r>
+              <a:rPr sz="1300" b="0" i="0" kern="0" spc="0">
                 <a:solidFill>
                   <a:srgbClr val="FFFFFF"/>
                 </a:solidFill>
@@ -7926,7 +7926,7 @@
               <a:t>de las </a:t>
             </a:r>
             <a:r>
-              <a:rPr sz="1650" b="1" i="0" kern="0" spc="0">
+              <a:rPr sz="1300" b="1" i="0" kern="0" spc="0">
                 <a:solidFill>
                   <a:srgbClr val="FFFFFF"/>
                 </a:solidFill>
@@ -7935,7 +7935,7 @@
               <a:t>mujeres</a:t>
             </a:r>
             <a:r>
-              <a:rPr sz="1650" b="0" i="0" kern="0" spc="0">
+              <a:rPr sz="1300" b="0" i="0" kern="0" spc="0">
                 <a:solidFill>
                   <a:srgbClr val="FFFFFF"/>
                 </a:solidFill>
@@ -7954,8 +7954,8 @@
         </p:nvSpPr>
         <p:spPr>
           <a:xfrm>
-            <a:off x="8001000" y="4762500"/>
-            <a:ext cx="8382000" cy="1905000"/>
+            <a:off x="10391775" y="4762500"/>
+            <a:ext cx="3600450" cy="1905000"/>
           </a:xfrm>
           <a:prstGeom prst="rect">
             <a:avLst/>
@@ -7989,23 +7989,23 @@
         </p:nvSpPr>
         <p:spPr>
           <a:xfrm>
-            <a:off x="8001000" y="6858000"/>
-            <a:ext cx="8382000" cy="1714500"/>
-          </a:xfrm>
-          <a:prstGeom prst="rect">
-            <a:avLst/>
-          </a:prstGeom>
-          <a:noFill/>
-        </p:spPr>
-        <p:txBody>
-          <a:bodyPr wrap="square" lIns="0" rIns="0" tIns="0" bIns="0">
-            <a:spAutoFit/>
-          </a:bodyPr>
-          <a:lstStyle/>
-          <a:p>
-            <a:pPr algn="ctr"/>
-            <a:r>
-              <a:rPr sz="1650" b="0" i="0" kern="0" spc="0">
+            <a:off x="10391775" y="6858000"/>
+            <a:ext cx="3600450" cy="1076325"/>
+          </a:xfrm>
+          <a:prstGeom prst="rect">
+            <a:avLst/>
+          </a:prstGeom>
+          <a:noFill/>
+        </p:spPr>
+        <p:txBody>
+          <a:bodyPr wrap="square" lIns="0" rIns="0" tIns="0" bIns="0">
+            <a:spAutoFit/>
+          </a:bodyPr>
+          <a:lstStyle/>
+          <a:p>
+            <a:pPr algn="ctr"/>
+            <a:r>
+              <a:rPr sz="1300" b="0" i="0" kern="0" spc="0">
                 <a:solidFill>
                   <a:srgbClr val="FFFFFF"/>
                 </a:solidFill>
@@ -8014,7 +8014,7 @@
               <a:t>de los jóvenes de </a:t>
             </a:r>
             <a:r>
-              <a:rPr sz="1650" b="1" i="0" kern="0" spc="0">
+              <a:rPr sz="1300" b="1" i="0" kern="0" spc="0">
                 <a:solidFill>
                   <a:srgbClr val="FFFFFF"/>
                 </a:solidFill>
@@ -8023,7 +8023,7 @@
               <a:t>18-24 años</a:t>
             </a:r>
             <a:r>
-              <a:rPr sz="1650" b="0" i="0" kern="0" spc="0">
+              <a:rPr sz="1300" b="0" i="0" kern="0" spc="0">
                 <a:solidFill>
                   <a:srgbClr val="FFFFFF"/>
                 </a:solidFill>
@@ -8119,7 +8119,7 @@
           <a:p>
             <a:pPr algn="ctr"/>
             <a:r>
-              <a:rPr sz="3150" b="0" i="0" kern="0" spc="0">
+              <a:rPr sz="5000" b="0" i="0" kern="0" spc="0">
                 <a:solidFill>
                   <a:srgbClr val="FFFFFF"/>
                 </a:solidFill>
@@ -8128,7 +8128,7 @@
               <a:t>77% DEL DOMINICANO VOTÓ EN LAS ÚLTIMAS ELECCIONES. EL MISMO PAÍS DECLARA 58% DE DESINTERÉS TOTAL EN POLÍTICA. </a:t>
             </a:r>
             <a:r>
-              <a:rPr sz="3150" b="0" i="1" kern="0" spc="0">
+              <a:rPr sz="5000" b="0" i="1" kern="0" spc="0">
                 <a:solidFill>
                   <a:srgbClr val="FFFFFF"/>
                 </a:solidFill>
@@ -8148,7 +8148,7 @@
         <p:spPr>
           <a:xfrm>
             <a:off x="9134475" y="4572000"/>
-            <a:ext cx="19050" cy="2647950"/>
+            <a:ext cx="19050" cy="1457325"/>
           </a:xfrm>
           <a:prstGeom prst="rect">
             <a:avLst/>
@@ -8190,8 +8190,8 @@
         </p:nvSpPr>
         <p:spPr>
           <a:xfrm>
-            <a:off x="1905000" y="4762500"/>
-            <a:ext cx="8382000" cy="1905000"/>
+            <a:off x="4295775" y="4762500"/>
+            <a:ext cx="3600450" cy="1905000"/>
           </a:xfrm>
           <a:prstGeom prst="rect">
             <a:avLst/>
@@ -8225,23 +8225,23 @@
         </p:nvSpPr>
         <p:spPr>
           <a:xfrm>
-            <a:off x="1905000" y="6858000"/>
-            <a:ext cx="8382000" cy="1714500"/>
-          </a:xfrm>
-          <a:prstGeom prst="rect">
-            <a:avLst/>
-          </a:prstGeom>
-          <a:noFill/>
-        </p:spPr>
-        <p:txBody>
-          <a:bodyPr wrap="square" lIns="0" rIns="0" tIns="0" bIns="0">
-            <a:spAutoFit/>
-          </a:bodyPr>
-          <a:lstStyle/>
-          <a:p>
-            <a:pPr algn="ctr"/>
-            <a:r>
-              <a:rPr sz="1650" b="0" i="0" kern="0" spc="0">
+            <a:off x="4295775" y="6858000"/>
+            <a:ext cx="3600450" cy="1076325"/>
+          </a:xfrm>
+          <a:prstGeom prst="rect">
+            <a:avLst/>
+          </a:prstGeom>
+          <a:noFill/>
+        </p:spPr>
+        <p:txBody>
+          <a:bodyPr wrap="square" lIns="0" rIns="0" tIns="0" bIns="0">
+            <a:spAutoFit/>
+          </a:bodyPr>
+          <a:lstStyle/>
+          <a:p>
+            <a:pPr algn="ctr"/>
+            <a:r>
+              <a:rPr sz="1300" b="0" i="0" kern="0" spc="0">
                 <a:solidFill>
                   <a:srgbClr val="FFFFFF"/>
                 </a:solidFill>
@@ -8250,7 +8250,7 @@
               <a:t>declara haber </a:t>
             </a:r>
             <a:r>
-              <a:rPr sz="1650" b="1" i="0" kern="0" spc="0">
+              <a:rPr sz="1300" b="1" i="0" kern="0" spc="0">
                 <a:solidFill>
                   <a:srgbClr val="FFFFFF"/>
                 </a:solidFill>
@@ -8259,7 +8259,7 @@
               <a:t>votado</a:t>
             </a:r>
             <a:r>
-              <a:rPr sz="1650" b="0" i="0" kern="0" spc="0">
+              <a:rPr sz="1300" b="0" i="0" kern="0" spc="0">
                 <a:solidFill>
                   <a:srgbClr val="FFFFFF"/>
                 </a:solidFill>
@@ -8278,8 +8278,8 @@
         </p:nvSpPr>
         <p:spPr>
           <a:xfrm>
-            <a:off x="8001000" y="4762500"/>
-            <a:ext cx="8382000" cy="1905000"/>
+            <a:off x="10391775" y="4762500"/>
+            <a:ext cx="3600450" cy="1905000"/>
           </a:xfrm>
           <a:prstGeom prst="rect">
             <a:avLst/>
@@ -8313,23 +8313,23 @@
         </p:nvSpPr>
         <p:spPr>
           <a:xfrm>
-            <a:off x="8001000" y="6858000"/>
-            <a:ext cx="8382000" cy="1714500"/>
-          </a:xfrm>
-          <a:prstGeom prst="rect">
-            <a:avLst/>
-          </a:prstGeom>
-          <a:noFill/>
-        </p:spPr>
-        <p:txBody>
-          <a:bodyPr wrap="square" lIns="0" rIns="0" tIns="0" bIns="0">
-            <a:spAutoFit/>
-          </a:bodyPr>
-          <a:lstStyle/>
-          <a:p>
-            <a:pPr algn="ctr"/>
-            <a:r>
-              <a:rPr sz="1650" b="0" i="0" kern="0" spc="0">
+            <a:off x="10391775" y="6858000"/>
+            <a:ext cx="3600450" cy="1076325"/>
+          </a:xfrm>
+          <a:prstGeom prst="rect">
+            <a:avLst/>
+          </a:prstGeom>
+          <a:noFill/>
+        </p:spPr>
+        <p:txBody>
+          <a:bodyPr wrap="square" lIns="0" rIns="0" tIns="0" bIns="0">
+            <a:spAutoFit/>
+          </a:bodyPr>
+          <a:lstStyle/>
+          <a:p>
+            <a:pPr algn="ctr"/>
+            <a:r>
+              <a:rPr sz="1300" b="0" i="0" kern="0" spc="0">
                 <a:solidFill>
                   <a:srgbClr val="FFFFFF"/>
                 </a:solidFill>
@@ -8338,7 +8338,7 @@
               <a:t>se declara "</a:t>
             </a:r>
             <a:r>
-              <a:rPr sz="1650" b="1" i="0" kern="0" spc="0">
+              <a:rPr sz="1300" b="1" i="0" kern="0" spc="0">
                 <a:solidFill>
                   <a:srgbClr val="FFFFFF"/>
                 </a:solidFill>
@@ -8347,7 +8347,7 @@
               <a:t>nada interesado</a:t>
             </a:r>
             <a:r>
-              <a:rPr sz="1650" b="0" i="0" kern="0" spc="0">
+              <a:rPr sz="1300" b="0" i="0" kern="0" spc="0">
                 <a:solidFill>
                   <a:srgbClr val="FFFFFF"/>
                 </a:solidFill>
@@ -8602,7 +8602,7 @@
           <a:p>
             <a:pPr algn="ctr"/>
             <a:r>
-              <a:rPr sz="3150" b="0" i="0" kern="0" spc="0">
+              <a:rPr sz="5000" b="0" i="0" kern="0" spc="0">
                 <a:solidFill>
                   <a:srgbClr val="FFFFFF"/>
                 </a:solidFill>
@@ -8611,7 +8611,7 @@
               <a:t>EL VOTO SUBE CON LA EDAD: 82% DE LOS MAYORES DE 55 VOTÓ, CONTRA 69% DE LOS 18-24. </a:t>
             </a:r>
             <a:r>
-              <a:rPr sz="3150" b="0" i="1" kern="0" spc="0">
+              <a:rPr sz="5000" b="0" i="1" kern="0" spc="0">
                 <a:solidFill>
                   <a:srgbClr val="FFFFFF"/>
                 </a:solidFill>
@@ -8631,7 +8631,7 @@
         <p:spPr>
           <a:xfrm>
             <a:off x="9134475" y="4572000"/>
-            <a:ext cx="19050" cy="2647950"/>
+            <a:ext cx="19050" cy="1457325"/>
           </a:xfrm>
           <a:prstGeom prst="rect">
             <a:avLst/>
@@ -8673,8 +8673,8 @@
         </p:nvSpPr>
         <p:spPr>
           <a:xfrm>
-            <a:off x="1905000" y="4762500"/>
-            <a:ext cx="8382000" cy="1905000"/>
+            <a:off x="4295775" y="4762500"/>
+            <a:ext cx="3600450" cy="1905000"/>
           </a:xfrm>
           <a:prstGeom prst="rect">
             <a:avLst/>
@@ -8708,23 +8708,23 @@
         </p:nvSpPr>
         <p:spPr>
           <a:xfrm>
-            <a:off x="1905000" y="6858000"/>
-            <a:ext cx="8382000" cy="1714500"/>
-          </a:xfrm>
-          <a:prstGeom prst="rect">
-            <a:avLst/>
-          </a:prstGeom>
-          <a:noFill/>
-        </p:spPr>
-        <p:txBody>
-          <a:bodyPr wrap="square" lIns="0" rIns="0" tIns="0" bIns="0">
-            <a:spAutoFit/>
-          </a:bodyPr>
-          <a:lstStyle/>
-          <a:p>
-            <a:pPr algn="ctr"/>
-            <a:r>
-              <a:rPr sz="1650" b="0" i="0" kern="0" spc="0">
+            <a:off x="4295775" y="6858000"/>
+            <a:ext cx="3600450" cy="1076325"/>
+          </a:xfrm>
+          <a:prstGeom prst="rect">
+            <a:avLst/>
+          </a:prstGeom>
+          <a:noFill/>
+        </p:spPr>
+        <p:txBody>
+          <a:bodyPr wrap="square" lIns="0" rIns="0" tIns="0" bIns="0">
+            <a:spAutoFit/>
+          </a:bodyPr>
+          <a:lstStyle/>
+          <a:p>
+            <a:pPr algn="ctr"/>
+            <a:r>
+              <a:rPr sz="1300" b="0" i="0" kern="0" spc="0">
                 <a:solidFill>
                   <a:srgbClr val="FFFFFF"/>
                 </a:solidFill>
@@ -8733,7 +8733,7 @@
               <a:t>de los mayores de </a:t>
             </a:r>
             <a:r>
-              <a:rPr sz="1650" b="1" i="0" kern="0" spc="0">
+              <a:rPr sz="1300" b="1" i="0" kern="0" spc="0">
                 <a:solidFill>
                   <a:srgbClr val="FFFFFF"/>
                 </a:solidFill>
@@ -8742,7 +8742,7 @@
               <a:t>55 años</a:t>
             </a:r>
             <a:r>
-              <a:rPr sz="1650" b="0" i="0" kern="0" spc="0">
+              <a:rPr sz="1300" b="0" i="0" kern="0" spc="0">
                 <a:solidFill>
                   <a:srgbClr val="FFFFFF"/>
                 </a:solidFill>
@@ -8761,8 +8761,8 @@
         </p:nvSpPr>
         <p:spPr>
           <a:xfrm>
-            <a:off x="8001000" y="4762500"/>
-            <a:ext cx="8382000" cy="1905000"/>
+            <a:off x="10391775" y="4762500"/>
+            <a:ext cx="3600450" cy="1905000"/>
           </a:xfrm>
           <a:prstGeom prst="rect">
             <a:avLst/>
@@ -8796,23 +8796,23 @@
         </p:nvSpPr>
         <p:spPr>
           <a:xfrm>
-            <a:off x="8001000" y="6858000"/>
-            <a:ext cx="8382000" cy="1714500"/>
-          </a:xfrm>
-          <a:prstGeom prst="rect">
-            <a:avLst/>
-          </a:prstGeom>
-          <a:noFill/>
-        </p:spPr>
-        <p:txBody>
-          <a:bodyPr wrap="square" lIns="0" rIns="0" tIns="0" bIns="0">
-            <a:spAutoFit/>
-          </a:bodyPr>
-          <a:lstStyle/>
-          <a:p>
-            <a:pPr algn="ctr"/>
-            <a:r>
-              <a:rPr sz="1650" b="0" i="0" kern="0" spc="0">
+            <a:off x="10391775" y="6858000"/>
+            <a:ext cx="3600450" cy="1076325"/>
+          </a:xfrm>
+          <a:prstGeom prst="rect">
+            <a:avLst/>
+          </a:prstGeom>
+          <a:noFill/>
+        </p:spPr>
+        <p:txBody>
+          <a:bodyPr wrap="square" lIns="0" rIns="0" tIns="0" bIns="0">
+            <a:spAutoFit/>
+          </a:bodyPr>
+          <a:lstStyle/>
+          <a:p>
+            <a:pPr algn="ctr"/>
+            <a:r>
+              <a:rPr sz="1300" b="0" i="0" kern="0" spc="0">
                 <a:solidFill>
                   <a:srgbClr val="FFFFFF"/>
                 </a:solidFill>
@@ -8821,7 +8821,7 @@
               <a:t>de los jóvenes de </a:t>
             </a:r>
             <a:r>
-              <a:rPr sz="1650" b="1" i="0" kern="0" spc="0">
+              <a:rPr sz="1300" b="1" i="0" kern="0" spc="0">
                 <a:solidFill>
                   <a:srgbClr val="FFFFFF"/>
                 </a:solidFill>
@@ -8830,7 +8830,7 @@
               <a:t>18-24</a:t>
             </a:r>
             <a:r>
-              <a:rPr sz="1650" b="0" i="0" kern="0" spc="0">
+              <a:rPr sz="1300" b="0" i="0" kern="0" spc="0">
                 <a:solidFill>
                   <a:srgbClr val="FFFFFF"/>
                 </a:solidFill>

</xml_diff>

<commit_message>
Fix slide cuali Opiniones Políticas + reforzar knowledge v6
- add_card ahora soporta is_cuali=True: padding 30/25 + Poppins 15pt + atribución italic 12pt
- build_cuali_slide pasa is_cuali=True para cards 567×227pt
- Slide 17 (cuali side by side) ahora se ve correctamente: cards rounded edges, texto Poppins centrado con padding compacto
- Knowledge reforzado: padding fix v6 (60×80 era para card legacy 1637×485; cards cuali 567×227 usan 30×25)
</commit_message>
<xml_diff>
--- a/Agentes Hallazgos/opiniones-politicas-deck-flat.pptx
+++ b/Agentes Hallazgos/opiniones-politicas-deck-flat.pptx
@@ -5182,27 +5182,27 @@
         </p:nvSpPr>
         <p:spPr>
           <a:xfrm>
-            <a:off x="4124325" y="4657725"/>
-            <a:ext cx="3876675" cy="1019175"/>
-          </a:xfrm>
-          <a:prstGeom prst="rect">
-            <a:avLst/>
-          </a:prstGeom>
-          <a:noFill/>
-        </p:spPr>
-        <p:txBody>
-          <a:bodyPr wrap="square" lIns="0" rIns="0" tIns="0" bIns="0">
-            <a:spAutoFit/>
-          </a:bodyPr>
-          <a:lstStyle/>
-          <a:p>
-            <a:pPr algn="ctr"/>
-            <a:r>
-              <a:rPr sz="5000" i="0" b="0" kern="0" spc="0">
-                <a:solidFill>
-                  <a:srgbClr val="FFFFFF"/>
-                </a:solidFill>
-                <a:latin typeface="Instrument Serif"/>
+            <a:off x="3648075" y="4324350"/>
+            <a:ext cx="4829175" cy="1685925"/>
+          </a:xfrm>
+          <a:prstGeom prst="rect">
+            <a:avLst/>
+          </a:prstGeom>
+          <a:noFill/>
+        </p:spPr>
+        <p:txBody>
+          <a:bodyPr wrap="square" lIns="0" rIns="0" tIns="0" bIns="0">
+            <a:spAutoFit/>
+          </a:bodyPr>
+          <a:lstStyle/>
+          <a:p>
+            <a:pPr algn="ctr"/>
+            <a:r>
+              <a:rPr sz="1500" i="0" b="0" kern="0" spc="0">
+                <a:solidFill>
+                  <a:srgbClr val="FFFFFF"/>
+                </a:solidFill>
+                <a:latin typeface="Poppins"/>
               </a:rPr>
               <a:t>«Cada vez que un político de esos se va con 500 millones de pesos, se llevó el puentecito que hace falta en los velaquitos, se llevó la carreterita de 4 kilómetros que tanto necesita, la escuela de los niños, la escuelita. Y se lo lleva a un solo personaje.»</a:t>
             </a:r>
@@ -5210,11 +5210,11 @@
           <a:p>
             <a:pPr algn="ctr">
               <a:spcBef>
-                <a:spcPts val="1000"/>
+                <a:spcPts val="800"/>
               </a:spcBef>
             </a:pPr>
             <a:r>
-              <a:rPr sz="1650" i="1" b="0" kern="0" spc="0">
+              <a:rPr sz="1200" i="1" b="0" kern="0" spc="0">
                 <a:solidFill>
                   <a:srgbClr val="FFFFFF"/>
                 </a:solidFill>
@@ -5280,27 +5280,27 @@
         </p:nvSpPr>
         <p:spPr>
           <a:xfrm>
-            <a:off x="10287000" y="4657725"/>
-            <a:ext cx="3876675" cy="1019175"/>
-          </a:xfrm>
-          <a:prstGeom prst="rect">
-            <a:avLst/>
-          </a:prstGeom>
-          <a:noFill/>
-        </p:spPr>
-        <p:txBody>
-          <a:bodyPr wrap="square" lIns="0" rIns="0" tIns="0" bIns="0">
-            <a:spAutoFit/>
-          </a:bodyPr>
-          <a:lstStyle/>
-          <a:p>
-            <a:pPr algn="ctr"/>
-            <a:r>
-              <a:rPr sz="5000" i="0" b="0" kern="0" spc="0">
-                <a:solidFill>
-                  <a:srgbClr val="FFFFFF"/>
-                </a:solidFill>
-                <a:latin typeface="Instrument Serif"/>
+            <a:off x="9810750" y="4324350"/>
+            <a:ext cx="4829175" cy="1685925"/>
+          </a:xfrm>
+          <a:prstGeom prst="rect">
+            <a:avLst/>
+          </a:prstGeom>
+          <a:noFill/>
+        </p:spPr>
+        <p:txBody>
+          <a:bodyPr wrap="square" lIns="0" rIns="0" tIns="0" bIns="0">
+            <a:spAutoFit/>
+          </a:bodyPr>
+          <a:lstStyle/>
+          <a:p>
+            <a:pPr algn="ctr"/>
+            <a:r>
+              <a:rPr sz="1500" i="0" b="0" kern="0" spc="0">
+                <a:solidFill>
+                  <a:srgbClr val="FFFFFF"/>
+                </a:solidFill>
+                <a:latin typeface="Poppins"/>
               </a:rPr>
               <a:t>«Y siempre que un cambio de gobierno (...) te ponen a una gente por encima de ti ganando muchísimo más que tú y no es ni profesional. Entonces tú recibir un mandato de una persona que sabe menos que tú.»</a:t>
             </a:r>
@@ -5308,11 +5308,11 @@
           <a:p>
             <a:pPr algn="ctr">
               <a:spcBef>
-                <a:spcPts val="1000"/>
+                <a:spcPts val="800"/>
               </a:spcBef>
             </a:pPr>
             <a:r>
-              <a:rPr sz="1650" i="1" b="0" kern="0" spc="0">
+              <a:rPr sz="1200" i="1" b="0" kern="0" spc="0">
                 <a:solidFill>
                   <a:srgbClr val="FFFFFF"/>
                 </a:solidFill>

</xml_diff>